<commit_message>
Deliver reliable planning, full PDF reading and local paper uploads
</commit_message>
<xml_diff>
--- a/PPT/PPT-Science-Bot.pptx
+++ b/PPT/PPT-Science-Bot.pptx
@@ -10,6 +10,9 @@
     <p:sldId id="258" r:id="rId4"/>
     <p:sldId id="259" r:id="rId5"/>
     <p:sldId id="260" r:id="rId6"/>
+    <p:sldId id="262" r:id="rId7"/>
+    <p:sldId id="261" r:id="rId8"/>
+    <p:sldId id="263" r:id="rId9"/>
   </p:sldIdLst>
   <p:sldSz cx="12192000" cy="6858000"/>
   <p:notesSz cx="6858000" cy="9144000"/>
@@ -263,7 +266,7 @@
           <a:p>
             <a:fld id="{5D2A73B6-57A9-4A13-8D84-34B79FB49C9C}" type="datetimeFigureOut">
               <a:rPr lang="zh-CN" altLang="en-US" smtClean="0"/>
-              <a:t>2026/10/29</a:t>
+              <a:t>2026/10/31</a:t>
             </a:fld>
             <a:endParaRPr lang="zh-CN" altLang="en-US"/>
           </a:p>
@@ -461,7 +464,7 @@
           <a:p>
             <a:fld id="{5D2A73B6-57A9-4A13-8D84-34B79FB49C9C}" type="datetimeFigureOut">
               <a:rPr lang="zh-CN" altLang="en-US" smtClean="0"/>
-              <a:t>2026/10/29</a:t>
+              <a:t>2026/10/31</a:t>
             </a:fld>
             <a:endParaRPr lang="zh-CN" altLang="en-US"/>
           </a:p>
@@ -669,7 +672,7 @@
           <a:p>
             <a:fld id="{5D2A73B6-57A9-4A13-8D84-34B79FB49C9C}" type="datetimeFigureOut">
               <a:rPr lang="zh-CN" altLang="en-US" smtClean="0"/>
-              <a:t>2026/10/29</a:t>
+              <a:t>2026/10/31</a:t>
             </a:fld>
             <a:endParaRPr lang="zh-CN" altLang="en-US"/>
           </a:p>
@@ -867,7 +870,7 @@
           <a:p>
             <a:fld id="{5D2A73B6-57A9-4A13-8D84-34B79FB49C9C}" type="datetimeFigureOut">
               <a:rPr lang="zh-CN" altLang="en-US" smtClean="0"/>
-              <a:t>2026/10/29</a:t>
+              <a:t>2026/10/31</a:t>
             </a:fld>
             <a:endParaRPr lang="zh-CN" altLang="en-US"/>
           </a:p>
@@ -1142,7 +1145,7 @@
           <a:p>
             <a:fld id="{5D2A73B6-57A9-4A13-8D84-34B79FB49C9C}" type="datetimeFigureOut">
               <a:rPr lang="zh-CN" altLang="en-US" smtClean="0"/>
-              <a:t>2026/10/29</a:t>
+              <a:t>2026/10/31</a:t>
             </a:fld>
             <a:endParaRPr lang="zh-CN" altLang="en-US"/>
           </a:p>
@@ -1407,7 +1410,7 @@
           <a:p>
             <a:fld id="{5D2A73B6-57A9-4A13-8D84-34B79FB49C9C}" type="datetimeFigureOut">
               <a:rPr lang="zh-CN" altLang="en-US" smtClean="0"/>
-              <a:t>2026/10/29</a:t>
+              <a:t>2026/10/31</a:t>
             </a:fld>
             <a:endParaRPr lang="zh-CN" altLang="en-US"/>
           </a:p>
@@ -1819,7 +1822,7 @@
           <a:p>
             <a:fld id="{5D2A73B6-57A9-4A13-8D84-34B79FB49C9C}" type="datetimeFigureOut">
               <a:rPr lang="zh-CN" altLang="en-US" smtClean="0"/>
-              <a:t>2026/10/29</a:t>
+              <a:t>2026/10/31</a:t>
             </a:fld>
             <a:endParaRPr lang="zh-CN" altLang="en-US"/>
           </a:p>
@@ -1960,7 +1963,7 @@
           <a:p>
             <a:fld id="{5D2A73B6-57A9-4A13-8D84-34B79FB49C9C}" type="datetimeFigureOut">
               <a:rPr lang="zh-CN" altLang="en-US" smtClean="0"/>
-              <a:t>2026/10/29</a:t>
+              <a:t>2026/10/31</a:t>
             </a:fld>
             <a:endParaRPr lang="zh-CN" altLang="en-US"/>
           </a:p>
@@ -2073,7 +2076,7 @@
           <a:p>
             <a:fld id="{5D2A73B6-57A9-4A13-8D84-34B79FB49C9C}" type="datetimeFigureOut">
               <a:rPr lang="zh-CN" altLang="en-US" smtClean="0"/>
-              <a:t>2026/10/29</a:t>
+              <a:t>2026/10/31</a:t>
             </a:fld>
             <a:endParaRPr lang="zh-CN" altLang="en-US"/>
           </a:p>
@@ -2384,7 +2387,7 @@
           <a:p>
             <a:fld id="{5D2A73B6-57A9-4A13-8D84-34B79FB49C9C}" type="datetimeFigureOut">
               <a:rPr lang="zh-CN" altLang="en-US" smtClean="0"/>
-              <a:t>2026/10/29</a:t>
+              <a:t>2026/10/31</a:t>
             </a:fld>
             <a:endParaRPr lang="zh-CN" altLang="en-US"/>
           </a:p>
@@ -2672,7 +2675,7 @@
           <a:p>
             <a:fld id="{5D2A73B6-57A9-4A13-8D84-34B79FB49C9C}" type="datetimeFigureOut">
               <a:rPr lang="zh-CN" altLang="en-US" smtClean="0"/>
-              <a:t>2026/10/29</a:t>
+              <a:t>2026/10/31</a:t>
             </a:fld>
             <a:endParaRPr lang="zh-CN" altLang="en-US"/>
           </a:p>
@@ -2913,7 +2916,7 @@
           <a:p>
             <a:fld id="{5D2A73B6-57A9-4A13-8D84-34B79FB49C9C}" type="datetimeFigureOut">
               <a:rPr lang="zh-CN" altLang="en-US" smtClean="0"/>
-              <a:t>2026/10/29</a:t>
+              <a:t>2026/10/31</a:t>
             </a:fld>
             <a:endParaRPr lang="zh-CN" altLang="en-US"/>
           </a:p>
@@ -3498,6 +3501,20 @@
               <a:t> control</a:t>
             </a:r>
           </a:p>
+          <a:p>
+            <a:endParaRPr lang="en-US" altLang="zh-CN" dirty="0"/>
+          </a:p>
+          <a:p>
+            <a:r>
+              <a:rPr lang="en-US" altLang="zh-CN" dirty="0"/>
+              <a:t>TODO</a:t>
+            </a:r>
+            <a:r>
+              <a:rPr lang="zh-CN" altLang="en-US" dirty="0"/>
+              <a:t>：在这里根据论文深入讨论；</a:t>
+            </a:r>
+            <a:endParaRPr lang="en-US" altLang="zh-CN" dirty="0"/>
+          </a:p>
         </p:txBody>
       </p:sp>
     </p:spTree>
@@ -3555,7 +3572,7 @@
           <a:p>
             <a:r>
               <a:rPr lang="en-US" altLang="zh-CN" sz="4000" dirty="0"/>
-              <a:t>Our thought: More Interaction before design</a:t>
+              <a:t>Our thought: More Interaction before design your proposal</a:t>
             </a:r>
             <a:endParaRPr lang="zh-CN" altLang="en-US" sz="4000" dirty="0"/>
           </a:p>
@@ -3586,7 +3603,19 @@
               <a:rPr lang="en-US" altLang="zh-CN" dirty="0"/>
               <a:t>Although AI-generated code itself may not necessarily hinder learning, developing your own competence requires more than just interacting with AI—you also need to be able to explain the implementation and predict the behavior.</a:t>
             </a:r>
-            <a:endParaRPr lang="zh-CN" altLang="en-US" dirty="0"/>
+          </a:p>
+          <a:p>
+            <a:endParaRPr lang="en-US" altLang="zh-CN" dirty="0"/>
+          </a:p>
+          <a:p>
+            <a:r>
+              <a:rPr lang="en-US" altLang="zh-CN" dirty="0"/>
+              <a:t>TODO</a:t>
+            </a:r>
+            <a:r>
+              <a:rPr lang="zh-CN" altLang="en-US" dirty="0"/>
+              <a:t>：进一步详细介绍我们的项目；</a:t>
+            </a:r>
           </a:p>
         </p:txBody>
       </p:sp>
@@ -3797,13 +3826,33 @@
           <a:p>
             <a:r>
               <a:rPr lang="en-US" altLang="zh-CN" dirty="0"/>
-              <a:t>Here we compare a </a:t>
-            </a:r>
-            <a:r>
-              <a:rPr lang="en-US" altLang="zh-CN"/>
-              <a:t>same task: </a:t>
-            </a:r>
-            <a:endParaRPr lang="zh-CN" altLang="en-US"/>
+              <a:t>Here we compare a same task: </a:t>
+            </a:r>
+          </a:p>
+          <a:p>
+            <a:endParaRPr lang="en-US" altLang="zh-CN" dirty="0"/>
+          </a:p>
+          <a:p>
+            <a:r>
+              <a:rPr lang="en-US" altLang="zh-CN" dirty="0"/>
+              <a:t>TODO</a:t>
+            </a:r>
+            <a:r>
+              <a:rPr lang="zh-CN" altLang="en-US" dirty="0"/>
+              <a:t>：根据示例输出展示我们的</a:t>
+            </a:r>
+            <a:r>
+              <a:rPr lang="en-US" altLang="zh-CN" dirty="0"/>
+              <a:t>Bot</a:t>
+            </a:r>
+            <a:r>
+              <a:rPr lang="zh-CN" altLang="en-US" dirty="0"/>
+              <a:t>的输出细节和通过对话规划设计的能力</a:t>
+            </a:r>
+            <a:endParaRPr lang="en-US" altLang="zh-CN"/>
+          </a:p>
+          <a:p>
+            <a:endParaRPr lang="zh-CN" altLang="en-US" dirty="0"/>
           </a:p>
         </p:txBody>
       </p:sp>
@@ -3811,6 +3860,268 @@
     <p:extLst>
       <p:ext uri="{BB962C8B-B14F-4D97-AF65-F5344CB8AC3E}">
         <p14:creationId xmlns:p14="http://schemas.microsoft.com/office/powerpoint/2010/main" val="3394688610"/>
+      </p:ext>
+    </p:extLst>
+  </p:cSld>
+  <p:clrMapOvr>
+    <a:masterClrMapping/>
+  </p:clrMapOvr>
+</p:sld>
+</file>
+
+<file path=ppt/slides/slide6.xml><?xml version="1.0" encoding="utf-8"?>
+<p:sld xmlns:a="http://schemas.openxmlformats.org/drawingml/2006/main" xmlns:r="http://schemas.openxmlformats.org/officeDocument/2006/relationships" xmlns:p="http://schemas.openxmlformats.org/presentationml/2006/main">
+  <p:cSld>
+    <p:spTree>
+      <p:nvGrpSpPr>
+        <p:cNvPr id="1" name=""/>
+        <p:cNvGrpSpPr/>
+        <p:nvPr/>
+      </p:nvGrpSpPr>
+      <p:grpSpPr>
+        <a:xfrm>
+          <a:off x="0" y="0"/>
+          <a:ext cx="0" cy="0"/>
+          <a:chOff x="0" y="0"/>
+          <a:chExt cx="0" cy="0"/>
+        </a:xfrm>
+      </p:grpSpPr>
+      <p:sp>
+        <p:nvSpPr>
+          <p:cNvPr id="2" name="标题 1">
+            <a:extLst>
+              <a:ext uri="{FF2B5EF4-FFF2-40B4-BE49-F238E27FC236}">
+                <a16:creationId xmlns:a16="http://schemas.microsoft.com/office/drawing/2014/main" id="{78160092-9C82-7B61-2D77-95E36437CB8B}"/>
+              </a:ext>
+            </a:extLst>
+          </p:cNvPr>
+          <p:cNvSpPr>
+            <a:spLocks noGrp="1"/>
+          </p:cNvSpPr>
+          <p:nvPr>
+            <p:ph type="title"/>
+          </p:nvPr>
+        </p:nvSpPr>
+        <p:spPr/>
+        <p:txBody>
+          <a:bodyPr/>
+          <a:lstStyle/>
+          <a:p>
+            <a:r>
+              <a:rPr lang="en-US" altLang="zh-CN" dirty="0"/>
+              <a:t>TODO</a:t>
+            </a:r>
+            <a:r>
+              <a:rPr lang="zh-CN" altLang="en-US" dirty="0"/>
+              <a:t>： 展示我们的交互界面并讲解用法</a:t>
+            </a:r>
+          </a:p>
+        </p:txBody>
+      </p:sp>
+      <p:pic>
+        <p:nvPicPr>
+          <p:cNvPr id="5" name="内容占位符 4">
+            <a:extLst>
+              <a:ext uri="{FF2B5EF4-FFF2-40B4-BE49-F238E27FC236}">
+                <a16:creationId xmlns:a16="http://schemas.microsoft.com/office/drawing/2014/main" id="{574CFB60-52CE-E7D8-FFB5-3127C8AC13F6}"/>
+              </a:ext>
+            </a:extLst>
+          </p:cNvPr>
+          <p:cNvPicPr>
+            <a:picLocks noGrp="1" noChangeAspect="1"/>
+          </p:cNvPicPr>
+          <p:nvPr>
+            <p:ph idx="1"/>
+          </p:nvPr>
+        </p:nvPicPr>
+        <p:blipFill>
+          <a:blip r:embed="rId2"/>
+          <a:stretch>
+            <a:fillRect/>
+          </a:stretch>
+        </p:blipFill>
+        <p:spPr>
+          <a:xfrm>
+            <a:off x="1794835" y="1825625"/>
+            <a:ext cx="8602330" cy="4351338"/>
+          </a:xfrm>
+          <a:prstGeom prst="rect">
+            <a:avLst/>
+          </a:prstGeom>
+        </p:spPr>
+      </p:pic>
+    </p:spTree>
+    <p:extLst>
+      <p:ext uri="{BB962C8B-B14F-4D97-AF65-F5344CB8AC3E}">
+        <p14:creationId xmlns:p14="http://schemas.microsoft.com/office/powerpoint/2010/main" val="940910632"/>
+      </p:ext>
+    </p:extLst>
+  </p:cSld>
+  <p:clrMapOvr>
+    <a:masterClrMapping/>
+  </p:clrMapOvr>
+</p:sld>
+</file>
+
+<file path=ppt/slides/slide7.xml><?xml version="1.0" encoding="utf-8"?>
+<p:sld xmlns:a="http://schemas.openxmlformats.org/drawingml/2006/main" xmlns:r="http://schemas.openxmlformats.org/officeDocument/2006/relationships" xmlns:p="http://schemas.openxmlformats.org/presentationml/2006/main">
+  <p:cSld>
+    <p:spTree>
+      <p:nvGrpSpPr>
+        <p:cNvPr id="1" name=""/>
+        <p:cNvGrpSpPr/>
+        <p:nvPr/>
+      </p:nvGrpSpPr>
+      <p:grpSpPr>
+        <a:xfrm>
+          <a:off x="0" y="0"/>
+          <a:ext cx="0" cy="0"/>
+          <a:chOff x="0" y="0"/>
+          <a:chExt cx="0" cy="0"/>
+        </a:xfrm>
+      </p:grpSpPr>
+      <p:sp>
+        <p:nvSpPr>
+          <p:cNvPr id="2" name="标题 1">
+            <a:extLst>
+              <a:ext uri="{FF2B5EF4-FFF2-40B4-BE49-F238E27FC236}">
+                <a16:creationId xmlns:a16="http://schemas.microsoft.com/office/drawing/2014/main" id="{AE40D3D4-4535-84E9-3C41-20A5A3DBB50D}"/>
+              </a:ext>
+            </a:extLst>
+          </p:cNvPr>
+          <p:cNvSpPr>
+            <a:spLocks noGrp="1"/>
+          </p:cNvSpPr>
+          <p:nvPr>
+            <p:ph type="title"/>
+          </p:nvPr>
+        </p:nvSpPr>
+        <p:spPr/>
+        <p:txBody>
+          <a:bodyPr/>
+          <a:lstStyle/>
+          <a:p>
+            <a:r>
+              <a:rPr lang="en-US" altLang="zh-CN" dirty="0"/>
+              <a:t>Visit our GitHub and learn more</a:t>
+            </a:r>
+            <a:endParaRPr lang="zh-CN" altLang="en-US" dirty="0"/>
+          </a:p>
+        </p:txBody>
+      </p:sp>
+      <p:sp>
+        <p:nvSpPr>
+          <p:cNvPr id="3" name="内容占位符 2">
+            <a:extLst>
+              <a:ext uri="{FF2B5EF4-FFF2-40B4-BE49-F238E27FC236}">
+                <a16:creationId xmlns:a16="http://schemas.microsoft.com/office/drawing/2014/main" id="{FE09CB9E-554D-46C4-5C39-8EC2EE25B591}"/>
+              </a:ext>
+            </a:extLst>
+          </p:cNvPr>
+          <p:cNvSpPr>
+            <a:spLocks noGrp="1"/>
+          </p:cNvSpPr>
+          <p:nvPr>
+            <p:ph idx="1"/>
+          </p:nvPr>
+        </p:nvSpPr>
+        <p:spPr/>
+        <p:txBody>
+          <a:bodyPr/>
+          <a:lstStyle/>
+          <a:p>
+            <a:endParaRPr lang="zh-CN" altLang="en-US" dirty="0"/>
+          </a:p>
+        </p:txBody>
+      </p:sp>
+    </p:spTree>
+    <p:extLst>
+      <p:ext uri="{BB962C8B-B14F-4D97-AF65-F5344CB8AC3E}">
+        <p14:creationId xmlns:p14="http://schemas.microsoft.com/office/powerpoint/2010/main" val="2105987854"/>
+      </p:ext>
+    </p:extLst>
+  </p:cSld>
+  <p:clrMapOvr>
+    <a:masterClrMapping/>
+  </p:clrMapOvr>
+</p:sld>
+</file>
+
+<file path=ppt/slides/slide8.xml><?xml version="1.0" encoding="utf-8"?>
+<p:sld xmlns:a="http://schemas.openxmlformats.org/drawingml/2006/main" xmlns:r="http://schemas.openxmlformats.org/officeDocument/2006/relationships" xmlns:p="http://schemas.openxmlformats.org/presentationml/2006/main">
+  <p:cSld>
+    <p:spTree>
+      <p:nvGrpSpPr>
+        <p:cNvPr id="1" name=""/>
+        <p:cNvGrpSpPr/>
+        <p:nvPr/>
+      </p:nvGrpSpPr>
+      <p:grpSpPr>
+        <a:xfrm>
+          <a:off x="0" y="0"/>
+          <a:ext cx="0" cy="0"/>
+          <a:chOff x="0" y="0"/>
+          <a:chExt cx="0" cy="0"/>
+        </a:xfrm>
+      </p:grpSpPr>
+      <p:sp>
+        <p:nvSpPr>
+          <p:cNvPr id="2" name="标题 1">
+            <a:extLst>
+              <a:ext uri="{FF2B5EF4-FFF2-40B4-BE49-F238E27FC236}">
+                <a16:creationId xmlns:a16="http://schemas.microsoft.com/office/drawing/2014/main" id="{A56CBAB0-9F14-4267-812D-649B340BC6D4}"/>
+              </a:ext>
+            </a:extLst>
+          </p:cNvPr>
+          <p:cNvSpPr>
+            <a:spLocks noGrp="1"/>
+          </p:cNvSpPr>
+          <p:nvPr>
+            <p:ph type="title"/>
+          </p:nvPr>
+        </p:nvSpPr>
+        <p:spPr/>
+        <p:txBody>
+          <a:bodyPr/>
+          <a:lstStyle/>
+          <a:p>
+            <a:r>
+              <a:rPr lang="en-US" altLang="zh-CN" dirty="0"/>
+              <a:t>Thanks for your attention</a:t>
+            </a:r>
+            <a:endParaRPr lang="zh-CN" altLang="en-US" dirty="0"/>
+          </a:p>
+        </p:txBody>
+      </p:sp>
+      <p:sp>
+        <p:nvSpPr>
+          <p:cNvPr id="3" name="内容占位符 2">
+            <a:extLst>
+              <a:ext uri="{FF2B5EF4-FFF2-40B4-BE49-F238E27FC236}">
+                <a16:creationId xmlns:a16="http://schemas.microsoft.com/office/drawing/2014/main" id="{F973EB5F-169C-E89F-FB88-2BBC172592C8}"/>
+              </a:ext>
+            </a:extLst>
+          </p:cNvPr>
+          <p:cNvSpPr>
+            <a:spLocks noGrp="1"/>
+          </p:cNvSpPr>
+          <p:nvPr>
+            <p:ph idx="1"/>
+          </p:nvPr>
+        </p:nvSpPr>
+        <p:spPr/>
+        <p:txBody>
+          <a:bodyPr/>
+          <a:lstStyle/>
+          <a:p>
+            <a:endParaRPr lang="zh-CN" altLang="en-US"/>
+          </a:p>
+        </p:txBody>
+      </p:sp>
+    </p:spTree>
+    <p:extLst>
+      <p:ext uri="{BB962C8B-B14F-4D97-AF65-F5344CB8AC3E}">
+        <p14:creationId xmlns:p14="http://schemas.microsoft.com/office/powerpoint/2010/main" val="1215614213"/>
       </p:ext>
     </p:extLst>
   </p:cSld>

</xml_diff>